<commit_message>
Add logo and register number to slides
</commit_message>
<xml_diff>
--- a/docs/TDMA_Scheduler_Presentation.pptx
+++ b/docs/TDMA_Scheduler_Presentation.pptx
@@ -119,18 +119,18 @@
   <p:extLst>
     <p:ext uri="{521415D9-36F7-43E2-AB2F-B90AF26B5E84}">
       <p14:sectionLst xmlns:p14="http://schemas.microsoft.com/office/powerpoint/2010/main">
-        <p14:section name="Opening" id="{ec66392f-853b-7a17-e4ee-7fe0d5ee3740}">
+        <p14:section name="Opening" id="{cfcc50dc-9291-01ef-400b-4d69043a4c33}">
           <p14:sldIdLst>
             <p14:sldId id="256"/>
           </p14:sldIdLst>
         </p14:section>
-        <p14:section name="Problem" id="{3d28fc4f-f996-93d6-0147-426faf0f30de}">
+        <p14:section name="Problem" id="{d3673a4d-b403-de69-0665-a315514a2fd2}">
           <p14:sldIdLst>
             <p14:sldId id="257"/>
             <p14:sldId id="258"/>
           </p14:sldIdLst>
         </p14:section>
-        <p14:section name="Part 1" id="{e33868a6-c945-7384-0062-c45c7b9e5e5a}">
+        <p14:section name="Part 1" id="{2ef34292-e6af-6b43-d80d-56cb3d7cde4b}">
           <p14:sldIdLst>
             <p14:sldId id="259"/>
             <p14:sldId id="260"/>
@@ -139,13 +139,13 @@
             <p14:sldId id="263"/>
           </p14:sldIdLst>
         </p14:section>
-        <p14:section name="Part 2" id="{f1ae8684-f011-2e9d-1891-48464d2d6c46}">
+        <p14:section name="Part 2" id="{1bd89be9-01e3-3809-2952-1ac0346f0615}">
           <p14:sldIdLst>
             <p14:sldId id="264"/>
             <p14:sldId id="265"/>
           </p14:sldIdLst>
         </p14:section>
-        <p14:section name="Wrap-up" id="{f065bfa8-dd9a-8dd9-a1fe-03cc22c3388b}">
+        <p14:section name="Wrap-up" id="{23bb411b-3b35-09e3-708a-73deb326ebcc}">
           <p14:sldIdLst>
             <p14:sldId id="266"/>
             <p14:sldId id="267"/>
@@ -3116,7 +3116,7 @@
         <p:spPr>
           <a:xfrm>
             <a:off x="640080" y="6035040"/>
-            <a:ext cx="9144000" cy="365760"/>
+            <a:ext cx="10058400" cy="365760"/>
           </a:xfrm>
           <a:prstGeom prst="rect">
             <a:avLst/>
@@ -3137,12 +3137,63 @@
                   <a:schemeClr val="accent6"/>
                 </a:solidFill>
               </a:rPr>
-              <a:t>Aadya Jain  ·  Vaan Megam Networks, Wireless Developer Internship</a:t>
+              <a:t>Aadya Jain  ·  Register No. RA2411003010085  ·  Wireless Developer Internship</a:t>
             </a:r>
             <a:endParaRPr lang="en-US" sz="1400" dirty="0"/>
           </a:p>
         </p:txBody>
       </p:sp>
+      <p:sp>
+        <p:nvSpPr>
+          <p:cNvPr id="9" name="logo card"/>
+          <p:cNvSpPr/>
+          <p:nvPr/>
+        </p:nvSpPr>
+        <p:spPr>
+          <a:xfrm>
+            <a:off x="9006840" y="502920"/>
+            <a:ext cx="2560320" cy="868680"/>
+          </a:xfrm>
+          <a:prstGeom prst="roundRect">
+            <a:avLst>
+              <a:gd name="adj" fmla="val 10526"/>
+            </a:avLst>
+          </a:prstGeom>
+          <a:solidFill>
+            <a:schemeClr val="bg1"/>
+          </a:solidFill>
+          <a:ln w="12700">
+            <a:solidFill>
+              <a:schemeClr val="bg1"/>
+            </a:solidFill>
+            <a:prstDash val="solid"/>
+          </a:ln>
+        </p:spPr>
+      </p:sp>
+      <p:pic>
+        <p:nvPicPr>
+          <p:cNvPr id="10" name="Image 0" descr="Vaan Megam Networks logo">    </p:cNvPr>
+          <p:cNvPicPr>
+            <a:picLocks noChangeAspect="1"/>
+          </p:cNvPicPr>
+          <p:nvPr/>
+        </p:nvPicPr>
+        <p:blipFill>
+          <a:blip r:embed="rId1"/>
+          <a:stretch>
+            <a:fillRect/>
+          </a:stretch>
+        </p:blipFill>
+        <p:spPr>
+          <a:xfrm>
+            <a:off x="9144000" y="621792"/>
+            <a:ext cx="2286000" cy="615863"/>
+          </a:xfrm>
+          <a:prstGeom prst="rect">
+            <a:avLst/>
+          </a:prstGeom>
+        </p:spPr>
+      </p:pic>
     </p:spTree>
   </p:cSld>
   <p:clrMapOvr>

</xml_diff>